<commit_message>
[doc] init design md
</commit_message>
<xml_diff>
--- a/doc/framework-roadmap-logo.pptx
+++ b/doc/framework-roadmap-logo.pptx
@@ -199,7 +199,7 @@
           <a:p>
             <a:fld id="{27A1F90A-33C7-4C1A-8B19-E7E0759E9529}" type="datetimeFigureOut">
               <a:rPr lang="zh-CN" altLang="en-US" smtClean="0"/>
-              <a:t>2022/5/11</a:t>
+              <a:t>2022/6/2</a:t>
             </a:fld>
             <a:endParaRPr lang="zh-CN" altLang="en-US"/>
           </a:p>
@@ -613,7 +613,7 @@
           <a:p>
             <a:fld id="{27C99010-58BF-43D2-A5A8-441DC26A885C}" type="datetimeFigureOut">
               <a:rPr lang="zh-CN" altLang="en-US" smtClean="0"/>
-              <a:t>2022/5/11</a:t>
+              <a:t>2022/6/2</a:t>
             </a:fld>
             <a:endParaRPr lang="zh-CN" altLang="en-US"/>
           </a:p>
@@ -811,7 +811,7 @@
           <a:p>
             <a:fld id="{27C99010-58BF-43D2-A5A8-441DC26A885C}" type="datetimeFigureOut">
               <a:rPr lang="zh-CN" altLang="en-US" smtClean="0"/>
-              <a:t>2022/5/11</a:t>
+              <a:t>2022/6/2</a:t>
             </a:fld>
             <a:endParaRPr lang="zh-CN" altLang="en-US"/>
           </a:p>
@@ -1019,7 +1019,7 @@
           <a:p>
             <a:fld id="{27C99010-58BF-43D2-A5A8-441DC26A885C}" type="datetimeFigureOut">
               <a:rPr lang="zh-CN" altLang="en-US" smtClean="0"/>
-              <a:t>2022/5/11</a:t>
+              <a:t>2022/6/2</a:t>
             </a:fld>
             <a:endParaRPr lang="zh-CN" altLang="en-US"/>
           </a:p>
@@ -1217,7 +1217,7 @@
           <a:p>
             <a:fld id="{27C99010-58BF-43D2-A5A8-441DC26A885C}" type="datetimeFigureOut">
               <a:rPr lang="zh-CN" altLang="en-US" smtClean="0"/>
-              <a:t>2022/5/11</a:t>
+              <a:t>2022/6/2</a:t>
             </a:fld>
             <a:endParaRPr lang="zh-CN" altLang="en-US"/>
           </a:p>
@@ -1492,7 +1492,7 @@
           <a:p>
             <a:fld id="{27C99010-58BF-43D2-A5A8-441DC26A885C}" type="datetimeFigureOut">
               <a:rPr lang="zh-CN" altLang="en-US" smtClean="0"/>
-              <a:t>2022/5/11</a:t>
+              <a:t>2022/6/2</a:t>
             </a:fld>
             <a:endParaRPr lang="zh-CN" altLang="en-US"/>
           </a:p>
@@ -1757,7 +1757,7 @@
           <a:p>
             <a:fld id="{27C99010-58BF-43D2-A5A8-441DC26A885C}" type="datetimeFigureOut">
               <a:rPr lang="zh-CN" altLang="en-US" smtClean="0"/>
-              <a:t>2022/5/11</a:t>
+              <a:t>2022/6/2</a:t>
             </a:fld>
             <a:endParaRPr lang="zh-CN" altLang="en-US"/>
           </a:p>
@@ -2169,7 +2169,7 @@
           <a:p>
             <a:fld id="{27C99010-58BF-43D2-A5A8-441DC26A885C}" type="datetimeFigureOut">
               <a:rPr lang="zh-CN" altLang="en-US" smtClean="0"/>
-              <a:t>2022/5/11</a:t>
+              <a:t>2022/6/2</a:t>
             </a:fld>
             <a:endParaRPr lang="zh-CN" altLang="en-US"/>
           </a:p>
@@ -2310,7 +2310,7 @@
           <a:p>
             <a:fld id="{27C99010-58BF-43D2-A5A8-441DC26A885C}" type="datetimeFigureOut">
               <a:rPr lang="zh-CN" altLang="en-US" smtClean="0"/>
-              <a:t>2022/5/11</a:t>
+              <a:t>2022/6/2</a:t>
             </a:fld>
             <a:endParaRPr lang="zh-CN" altLang="en-US"/>
           </a:p>
@@ -2423,7 +2423,7 @@
           <a:p>
             <a:fld id="{27C99010-58BF-43D2-A5A8-441DC26A885C}" type="datetimeFigureOut">
               <a:rPr lang="zh-CN" altLang="en-US" smtClean="0"/>
-              <a:t>2022/5/11</a:t>
+              <a:t>2022/6/2</a:t>
             </a:fld>
             <a:endParaRPr lang="zh-CN" altLang="en-US"/>
           </a:p>
@@ -2734,7 +2734,7 @@
           <a:p>
             <a:fld id="{27C99010-58BF-43D2-A5A8-441DC26A885C}" type="datetimeFigureOut">
               <a:rPr lang="zh-CN" altLang="en-US" smtClean="0"/>
-              <a:t>2022/5/11</a:t>
+              <a:t>2022/6/2</a:t>
             </a:fld>
             <a:endParaRPr lang="zh-CN" altLang="en-US"/>
           </a:p>
@@ -3022,7 +3022,7 @@
           <a:p>
             <a:fld id="{27C99010-58BF-43D2-A5A8-441DC26A885C}" type="datetimeFigureOut">
               <a:rPr lang="zh-CN" altLang="en-US" smtClean="0"/>
-              <a:t>2022/5/11</a:t>
+              <a:t>2022/6/2</a:t>
             </a:fld>
             <a:endParaRPr lang="zh-CN" altLang="en-US"/>
           </a:p>
@@ -3263,7 +3263,7 @@
           <a:p>
             <a:fld id="{27C99010-58BF-43D2-A5A8-441DC26A885C}" type="datetimeFigureOut">
               <a:rPr lang="zh-CN" altLang="en-US" smtClean="0"/>
-              <a:t>2022/5/11</a:t>
+              <a:t>2022/6/2</a:t>
             </a:fld>
             <a:endParaRPr lang="zh-CN" altLang="en-US"/>
           </a:p>
@@ -3971,17 +3971,13 @@
           <a:p>
             <a:r>
               <a:rPr lang="en-US" altLang="zh-CN" b="1" dirty="0"/>
-              <a:t>2022/4:</a:t>
+              <a:t>2022/6/1:</a:t>
             </a:r>
           </a:p>
           <a:p>
             <a:r>
               <a:rPr lang="zh-CN" altLang="en-US" dirty="0"/>
-              <a:t>完成</a:t>
-            </a:r>
-            <a:r>
-              <a:rPr lang="en-US" altLang="zh-CN" dirty="0" err="1"/>
-              <a:t>xxxx</a:t>
+              <a:t>完成初步设计</a:t>
             </a:r>
             <a:endParaRPr lang="en-US" altLang="zh-CN" dirty="0"/>
           </a:p>
@@ -4001,8 +3997,8 @@
         </p:nvSpPr>
         <p:spPr>
           <a:xfrm>
-            <a:off x="2602089" y="1629769"/>
-            <a:ext cx="2156178" cy="646331"/>
+            <a:off x="2602089" y="1503781"/>
+            <a:ext cx="2714979" cy="923330"/>
           </a:xfrm>
           <a:prstGeom prst="rect">
             <a:avLst/>
@@ -4023,7 +4019,7 @@
           <a:p>
             <a:r>
               <a:rPr lang="en-US" altLang="zh-CN" b="1" dirty="0"/>
-              <a:t>2022/6:</a:t>
+              <a:t>2022/6/30:</a:t>
             </a:r>
           </a:p>
           <a:p>
@@ -4033,9 +4029,22 @@
             </a:r>
             <a:r>
               <a:rPr lang="en-US" altLang="zh-CN" dirty="0"/>
-              <a:t>xxx</a:t>
-            </a:r>
-            <a:endParaRPr lang="zh-CN" altLang="en-US" dirty="0"/>
+              <a:t>buffer/sink/source</a:t>
+            </a:r>
+          </a:p>
+          <a:p>
+            <a:r>
+              <a:rPr lang="zh-CN" altLang="en-US" dirty="0"/>
+              <a:t>并</a:t>
+            </a:r>
+            <a:r>
+              <a:rPr lang="en-US" altLang="zh-CN" dirty="0"/>
+              <a:t>release v0.01</a:t>
+            </a:r>
+            <a:r>
+              <a:rPr lang="zh-CN" altLang="en-US" dirty="0"/>
+              <a:t>版本</a:t>
+            </a:r>
           </a:p>
         </p:txBody>
       </p:sp>
@@ -4053,8 +4062,8 @@
         </p:nvSpPr>
         <p:spPr>
           <a:xfrm>
-            <a:off x="5164667" y="2984522"/>
-            <a:ext cx="2156178" cy="923330"/>
+            <a:off x="5164666" y="2984522"/>
+            <a:ext cx="2576661" cy="923330"/>
           </a:xfrm>
           <a:prstGeom prst="rect">
             <a:avLst/>
@@ -4075,21 +4084,31 @@
           <a:p>
             <a:r>
               <a:rPr lang="en-US" altLang="zh-CN" b="1" dirty="0"/>
-              <a:t>2022/9:</a:t>
-            </a:r>
-          </a:p>
-          <a:p>
+              <a:t>2022/7:</a:t>
+            </a:r>
+          </a:p>
+          <a:p>
+            <a:r>
+              <a:rPr lang="zh-CN" altLang="en-US" dirty="0"/>
+              <a:t>完成</a:t>
+            </a:r>
             <a:r>
               <a:rPr lang="en-US" altLang="zh-CN" dirty="0"/>
-              <a:t>LLT</a:t>
-            </a:r>
-            <a:r>
-              <a:rPr lang="zh-CN" altLang="en-US" dirty="0"/>
-              <a:t>覆盖并</a:t>
+              <a:t>cipher/</a:t>
+            </a:r>
+            <a:r>
+              <a:rPr lang="en-US" altLang="zh-CN" dirty="0" err="1"/>
+              <a:t>gzip</a:t>
             </a:r>
             <a:r>
               <a:rPr lang="en-US" altLang="zh-CN" dirty="0"/>
-              <a:t>release v0.0.1</a:t>
+              <a:t>/</a:t>
+            </a:r>
+          </a:p>
+          <a:p>
+            <a:r>
+              <a:rPr lang="en-US" altLang="zh-CN" dirty="0"/>
+              <a:t>hashing/forwarding</a:t>
             </a:r>
             <a:endParaRPr lang="zh-CN" altLang="en-US" dirty="0"/>
           </a:p>
@@ -4131,7 +4150,7 @@
           <a:p>
             <a:r>
               <a:rPr lang="en-US" altLang="zh-CN" b="1" dirty="0"/>
-              <a:t>2023</a:t>
+              <a:t>2022/9</a:t>
             </a:r>
             <a:r>
               <a:rPr lang="zh-CN" altLang="en-US" b="1" dirty="0"/>
@@ -4183,10 +4202,10 @@
       </p:grpSpPr>
       <p:sp>
         <p:nvSpPr>
-          <p:cNvPr id="2" name="矩形 1">
-            <a:extLst>
-              <a:ext uri="{FF2B5EF4-FFF2-40B4-BE49-F238E27FC236}">
-                <a16:creationId xmlns:a16="http://schemas.microsoft.com/office/drawing/2014/main" id="{EBD35AE1-F2CF-4136-A1A4-C3AB74DBB7A5}"/>
+          <p:cNvPr id="15" name="椭圆 14">
+            <a:extLst>
+              <a:ext uri="{FF2B5EF4-FFF2-40B4-BE49-F238E27FC236}">
+                <a16:creationId xmlns:a16="http://schemas.microsoft.com/office/drawing/2014/main" id="{D4A93BE1-9C75-C912-AA39-A61A173520E3}"/>
               </a:ext>
             </a:extLst>
           </p:cNvPr>
@@ -4195,10 +4214,62 @@
         </p:nvSpPr>
         <p:spPr>
           <a:xfrm>
-            <a:off x="3702758" y="2465407"/>
-            <a:ext cx="3567286" cy="2060293"/>
+            <a:off x="3257182" y="1491969"/>
+            <a:ext cx="8301543" cy="4265512"/>
           </a:xfrm>
-          <a:prstGeom prst="rect">
+          <a:prstGeom prst="ellipse">
+            <a:avLst/>
+          </a:prstGeom>
+          <a:solidFill>
+            <a:schemeClr val="accent1">
+              <a:lumMod val="60000"/>
+              <a:lumOff val="40000"/>
+            </a:schemeClr>
+          </a:solidFill>
+        </p:spPr>
+        <p:style>
+          <a:lnRef idx="2">
+            <a:schemeClr val="accent1">
+              <a:shade val="50000"/>
+            </a:schemeClr>
+          </a:lnRef>
+          <a:fillRef idx="1">
+            <a:schemeClr val="accent1"/>
+          </a:fillRef>
+          <a:effectRef idx="0">
+            <a:schemeClr val="accent1"/>
+          </a:effectRef>
+          <a:fontRef idx="minor">
+            <a:schemeClr val="lt1"/>
+          </a:fontRef>
+        </p:style>
+        <p:txBody>
+          <a:bodyPr rtlCol="0" anchor="ctr"/>
+          <a:lstStyle/>
+          <a:p>
+            <a:pPr algn="ctr"/>
+            <a:endParaRPr lang="zh-CN" altLang="en-US" b="1"/>
+          </a:p>
+        </p:txBody>
+      </p:sp>
+      <p:sp>
+        <p:nvSpPr>
+          <p:cNvPr id="3" name="椭圆 2">
+            <a:extLst>
+              <a:ext uri="{FF2B5EF4-FFF2-40B4-BE49-F238E27FC236}">
+                <a16:creationId xmlns:a16="http://schemas.microsoft.com/office/drawing/2014/main" id="{2A9BBCED-3ED2-0809-FAE2-76C6A9EC7F4F}"/>
+              </a:ext>
+            </a:extLst>
+          </p:cNvPr>
+          <p:cNvSpPr/>
+          <p:nvPr/>
+        </p:nvSpPr>
+        <p:spPr>
+          <a:xfrm>
+            <a:off x="6096000" y="2681056"/>
+            <a:ext cx="2426563" cy="1294938"/>
+          </a:xfrm>
+          <a:prstGeom prst="ellipse">
             <a:avLst/>
           </a:prstGeom>
         </p:spPr>
@@ -4223,7 +4294,7 @@
           <a:lstStyle/>
           <a:p>
             <a:pPr algn="ctr"/>
-            <a:endParaRPr lang="zh-CN" altLang="en-US" dirty="0"/>
+            <a:endParaRPr lang="zh-CN" altLang="en-US" b="1"/>
           </a:p>
         </p:txBody>
       </p:sp>
@@ -4241,12 +4312,16 @@
         </p:nvSpPr>
         <p:spPr>
           <a:xfrm>
-            <a:off x="3790709" y="2992054"/>
-            <a:ext cx="3391383" cy="1244279"/>
+            <a:off x="6423420" y="3115601"/>
+            <a:ext cx="1771721" cy="425848"/>
           </a:xfrm>
           <a:prstGeom prst="rect">
             <a:avLst/>
           </a:prstGeom>
+          <a:noFill/>
+          <a:ln>
+            <a:noFill/>
+          </a:ln>
         </p:spPr>
         <p:style>
           <a:lnRef idx="2">
@@ -4270,10 +4345,10 @@
           <a:p>
             <a:pPr algn="ctr"/>
             <a:r>
-              <a:rPr lang="en-US" altLang="zh-CN" dirty="0"/>
-              <a:t>core</a:t>
-            </a:r>
-            <a:endParaRPr lang="zh-CN" altLang="en-US" dirty="0"/>
+              <a:rPr lang="en-US" altLang="zh-CN" b="1" dirty="0"/>
+              <a:t>Sink/Source</a:t>
+            </a:r>
+            <a:endParaRPr lang="zh-CN" altLang="en-US" b="1" dirty="0"/>
           </a:p>
         </p:txBody>
       </p:sp>
@@ -4291,8 +4366,8 @@
         </p:nvSpPr>
         <p:spPr>
           <a:xfrm>
-            <a:off x="4865877" y="1991374"/>
-            <a:ext cx="1317990" cy="369332"/>
+            <a:off x="6422578" y="956289"/>
+            <a:ext cx="1353256" cy="369332"/>
           </a:xfrm>
           <a:prstGeom prst="rect">
             <a:avLst/>
@@ -4307,7 +4382,379 @@
           <a:p>
             <a:r>
               <a:rPr lang="en-US" altLang="zh-CN" b="1" dirty="0"/>
-              <a:t>framework</a:t>
+              <a:t>Framework</a:t>
+            </a:r>
+            <a:endParaRPr lang="zh-CN" altLang="en-US" b="1" dirty="0"/>
+          </a:p>
+        </p:txBody>
+      </p:sp>
+      <p:sp>
+        <p:nvSpPr>
+          <p:cNvPr id="6" name="矩形 5">
+            <a:extLst>
+              <a:ext uri="{FF2B5EF4-FFF2-40B4-BE49-F238E27FC236}">
+                <a16:creationId xmlns:a16="http://schemas.microsoft.com/office/drawing/2014/main" id="{451D0AB8-6341-140F-F844-807337C9BA4B}"/>
+              </a:ext>
+            </a:extLst>
+          </p:cNvPr>
+          <p:cNvSpPr/>
+          <p:nvPr/>
+        </p:nvSpPr>
+        <p:spPr>
+          <a:xfrm>
+            <a:off x="3933502" y="2500425"/>
+            <a:ext cx="2209116" cy="673226"/>
+          </a:xfrm>
+          <a:prstGeom prst="rect">
+            <a:avLst/>
+          </a:prstGeom>
+          <a:noFill/>
+          <a:ln>
+            <a:noFill/>
+          </a:ln>
+        </p:spPr>
+        <p:style>
+          <a:lnRef idx="2">
+            <a:schemeClr val="accent6">
+              <a:shade val="50000"/>
+            </a:schemeClr>
+          </a:lnRef>
+          <a:fillRef idx="1">
+            <a:schemeClr val="accent6"/>
+          </a:fillRef>
+          <a:effectRef idx="0">
+            <a:schemeClr val="accent6"/>
+          </a:effectRef>
+          <a:fontRef idx="minor">
+            <a:schemeClr val="lt1"/>
+          </a:fontRef>
+        </p:style>
+        <p:txBody>
+          <a:bodyPr rtlCol="0" anchor="ctr"/>
+          <a:lstStyle/>
+          <a:p>
+            <a:pPr algn="ctr"/>
+            <a:r>
+              <a:rPr lang="en-US" altLang="zh-CN" b="1" dirty="0" err="1"/>
+              <a:t>BufferedSink</a:t>
+            </a:r>
+            <a:endParaRPr lang="en-US" altLang="zh-CN" b="1" dirty="0"/>
+          </a:p>
+          <a:p>
+            <a:pPr algn="ctr"/>
+            <a:r>
+              <a:rPr lang="en-US" altLang="zh-CN" b="1" dirty="0" err="1"/>
+              <a:t>BufferedSource</a:t>
+            </a:r>
+            <a:endParaRPr lang="zh-CN" altLang="en-US" b="1" dirty="0"/>
+          </a:p>
+        </p:txBody>
+      </p:sp>
+      <p:sp>
+        <p:nvSpPr>
+          <p:cNvPr id="9" name="矩形 8">
+            <a:extLst>
+              <a:ext uri="{FF2B5EF4-FFF2-40B4-BE49-F238E27FC236}">
+                <a16:creationId xmlns:a16="http://schemas.microsoft.com/office/drawing/2014/main" id="{04EDD9C4-3748-557C-E596-754DE2B246EF}"/>
+              </a:ext>
+            </a:extLst>
+          </p:cNvPr>
+          <p:cNvSpPr/>
+          <p:nvPr/>
+        </p:nvSpPr>
+        <p:spPr>
+          <a:xfrm>
+            <a:off x="3886882" y="3559437"/>
+            <a:ext cx="2209118" cy="702537"/>
+          </a:xfrm>
+          <a:prstGeom prst="rect">
+            <a:avLst/>
+          </a:prstGeom>
+          <a:noFill/>
+          <a:ln>
+            <a:noFill/>
+          </a:ln>
+        </p:spPr>
+        <p:style>
+          <a:lnRef idx="2">
+            <a:schemeClr val="accent6">
+              <a:shade val="50000"/>
+            </a:schemeClr>
+          </a:lnRef>
+          <a:fillRef idx="1">
+            <a:schemeClr val="accent6"/>
+          </a:fillRef>
+          <a:effectRef idx="0">
+            <a:schemeClr val="accent6"/>
+          </a:effectRef>
+          <a:fontRef idx="minor">
+            <a:schemeClr val="lt1"/>
+          </a:fontRef>
+        </p:style>
+        <p:txBody>
+          <a:bodyPr rtlCol="0" anchor="ctr"/>
+          <a:lstStyle/>
+          <a:p>
+            <a:pPr algn="ctr"/>
+            <a:r>
+              <a:rPr lang="en-US" altLang="zh-CN" b="1" dirty="0" err="1"/>
+              <a:t>ForwardingSink</a:t>
+            </a:r>
+            <a:endParaRPr lang="en-US" altLang="zh-CN" b="1" dirty="0"/>
+          </a:p>
+          <a:p>
+            <a:pPr algn="ctr"/>
+            <a:r>
+              <a:rPr lang="en-US" altLang="zh-CN" b="1" dirty="0" err="1"/>
+              <a:t>ForwardingSource</a:t>
+            </a:r>
+            <a:endParaRPr lang="zh-CN" altLang="en-US" b="1" dirty="0"/>
+          </a:p>
+        </p:txBody>
+      </p:sp>
+      <p:sp>
+        <p:nvSpPr>
+          <p:cNvPr id="11" name="矩形 10">
+            <a:extLst>
+              <a:ext uri="{FF2B5EF4-FFF2-40B4-BE49-F238E27FC236}">
+                <a16:creationId xmlns:a16="http://schemas.microsoft.com/office/drawing/2014/main" id="{B64ED98F-7AEE-58A3-9623-D01027BD1185}"/>
+              </a:ext>
+            </a:extLst>
+          </p:cNvPr>
+          <p:cNvSpPr/>
+          <p:nvPr/>
+        </p:nvSpPr>
+        <p:spPr>
+          <a:xfrm>
+            <a:off x="5948005" y="1830523"/>
+            <a:ext cx="2209118" cy="702537"/>
+          </a:xfrm>
+          <a:prstGeom prst="rect">
+            <a:avLst/>
+          </a:prstGeom>
+          <a:noFill/>
+          <a:ln>
+            <a:noFill/>
+          </a:ln>
+        </p:spPr>
+        <p:style>
+          <a:lnRef idx="2">
+            <a:schemeClr val="accent6">
+              <a:shade val="50000"/>
+            </a:schemeClr>
+          </a:lnRef>
+          <a:fillRef idx="1">
+            <a:schemeClr val="accent6"/>
+          </a:fillRef>
+          <a:effectRef idx="0">
+            <a:schemeClr val="accent6"/>
+          </a:effectRef>
+          <a:fontRef idx="minor">
+            <a:schemeClr val="lt1"/>
+          </a:fontRef>
+        </p:style>
+        <p:txBody>
+          <a:bodyPr rtlCol="0" anchor="ctr"/>
+          <a:lstStyle/>
+          <a:p>
+            <a:pPr algn="ctr"/>
+            <a:r>
+              <a:rPr lang="en-US" altLang="zh-CN" b="1" dirty="0" err="1"/>
+              <a:t>CipherSink</a:t>
+            </a:r>
+            <a:endParaRPr lang="en-US" altLang="zh-CN" b="1" dirty="0"/>
+          </a:p>
+          <a:p>
+            <a:pPr algn="ctr"/>
+            <a:r>
+              <a:rPr lang="en-US" altLang="zh-CN" b="1" dirty="0" err="1"/>
+              <a:t>CipherSource</a:t>
+            </a:r>
+            <a:endParaRPr lang="zh-CN" altLang="en-US" b="1" dirty="0"/>
+          </a:p>
+        </p:txBody>
+      </p:sp>
+      <p:sp>
+        <p:nvSpPr>
+          <p:cNvPr id="12" name="矩形 11">
+            <a:extLst>
+              <a:ext uri="{FF2B5EF4-FFF2-40B4-BE49-F238E27FC236}">
+                <a16:creationId xmlns:a16="http://schemas.microsoft.com/office/drawing/2014/main" id="{3CFB86DE-ACF2-3CC4-BFE0-16CD8E87B83A}"/>
+              </a:ext>
+            </a:extLst>
+          </p:cNvPr>
+          <p:cNvSpPr/>
+          <p:nvPr/>
+        </p:nvSpPr>
+        <p:spPr>
+          <a:xfrm>
+            <a:off x="5906552" y="4193266"/>
+            <a:ext cx="2209118" cy="702537"/>
+          </a:xfrm>
+          <a:prstGeom prst="rect">
+            <a:avLst/>
+          </a:prstGeom>
+          <a:noFill/>
+          <a:ln>
+            <a:noFill/>
+          </a:ln>
+        </p:spPr>
+        <p:style>
+          <a:lnRef idx="2">
+            <a:schemeClr val="accent6">
+              <a:shade val="50000"/>
+            </a:schemeClr>
+          </a:lnRef>
+          <a:fillRef idx="1">
+            <a:schemeClr val="accent6"/>
+          </a:fillRef>
+          <a:effectRef idx="0">
+            <a:schemeClr val="accent6"/>
+          </a:effectRef>
+          <a:fontRef idx="minor">
+            <a:schemeClr val="lt1"/>
+          </a:fontRef>
+        </p:style>
+        <p:txBody>
+          <a:bodyPr rtlCol="0" anchor="ctr"/>
+          <a:lstStyle/>
+          <a:p>
+            <a:pPr algn="ctr"/>
+            <a:r>
+              <a:rPr lang="en-US" altLang="zh-CN" b="1" dirty="0" err="1"/>
+              <a:t>GzipSink</a:t>
+            </a:r>
+            <a:endParaRPr lang="en-US" altLang="zh-CN" b="1" dirty="0"/>
+          </a:p>
+          <a:p>
+            <a:pPr algn="ctr"/>
+            <a:r>
+              <a:rPr lang="en-US" altLang="zh-CN" b="1" dirty="0" err="1"/>
+              <a:t>GzipSource</a:t>
+            </a:r>
+            <a:endParaRPr lang="zh-CN" altLang="en-US" b="1" dirty="0"/>
+          </a:p>
+        </p:txBody>
+      </p:sp>
+      <p:sp>
+        <p:nvSpPr>
+          <p:cNvPr id="13" name="矩形 12">
+            <a:extLst>
+              <a:ext uri="{FF2B5EF4-FFF2-40B4-BE49-F238E27FC236}">
+                <a16:creationId xmlns:a16="http://schemas.microsoft.com/office/drawing/2014/main" id="{4FB8B1C5-F3C5-FCC3-33B1-DF19FF41DAE1}"/>
+              </a:ext>
+            </a:extLst>
+          </p:cNvPr>
+          <p:cNvSpPr/>
+          <p:nvPr/>
+        </p:nvSpPr>
+        <p:spPr>
+          <a:xfrm>
+            <a:off x="8305116" y="2329788"/>
+            <a:ext cx="2209118" cy="702537"/>
+          </a:xfrm>
+          <a:prstGeom prst="rect">
+            <a:avLst/>
+          </a:prstGeom>
+          <a:noFill/>
+          <a:ln>
+            <a:noFill/>
+          </a:ln>
+        </p:spPr>
+        <p:style>
+          <a:lnRef idx="2">
+            <a:schemeClr val="accent6">
+              <a:shade val="50000"/>
+            </a:schemeClr>
+          </a:lnRef>
+          <a:fillRef idx="1">
+            <a:schemeClr val="accent6"/>
+          </a:fillRef>
+          <a:effectRef idx="0">
+            <a:schemeClr val="accent6"/>
+          </a:effectRef>
+          <a:fontRef idx="minor">
+            <a:schemeClr val="lt1"/>
+          </a:fontRef>
+        </p:style>
+        <p:txBody>
+          <a:bodyPr rtlCol="0" anchor="ctr"/>
+          <a:lstStyle/>
+          <a:p>
+            <a:pPr algn="ctr"/>
+            <a:r>
+              <a:rPr lang="en-US" altLang="zh-CN" b="1" dirty="0" err="1"/>
+              <a:t>HashingSink</a:t>
+            </a:r>
+            <a:endParaRPr lang="en-US" altLang="zh-CN" b="1" dirty="0"/>
+          </a:p>
+          <a:p>
+            <a:pPr algn="ctr"/>
+            <a:r>
+              <a:rPr lang="en-US" altLang="zh-CN" b="1" dirty="0" err="1"/>
+              <a:t>HashingSource</a:t>
+            </a:r>
+            <a:endParaRPr lang="zh-CN" altLang="en-US" b="1" dirty="0"/>
+          </a:p>
+        </p:txBody>
+      </p:sp>
+      <p:sp>
+        <p:nvSpPr>
+          <p:cNvPr id="14" name="矩形 13">
+            <a:extLst>
+              <a:ext uri="{FF2B5EF4-FFF2-40B4-BE49-F238E27FC236}">
+                <a16:creationId xmlns:a16="http://schemas.microsoft.com/office/drawing/2014/main" id="{B7C3C606-B356-F60B-FEB5-27ADE9FEC560}"/>
+              </a:ext>
+            </a:extLst>
+          </p:cNvPr>
+          <p:cNvSpPr/>
+          <p:nvPr/>
+        </p:nvSpPr>
+        <p:spPr>
+          <a:xfrm>
+            <a:off x="8393450" y="3624725"/>
+            <a:ext cx="2209118" cy="702537"/>
+          </a:xfrm>
+          <a:prstGeom prst="rect">
+            <a:avLst/>
+          </a:prstGeom>
+          <a:noFill/>
+          <a:ln>
+            <a:noFill/>
+          </a:ln>
+        </p:spPr>
+        <p:style>
+          <a:lnRef idx="2">
+            <a:schemeClr val="accent6">
+              <a:shade val="50000"/>
+            </a:schemeClr>
+          </a:lnRef>
+          <a:fillRef idx="1">
+            <a:schemeClr val="accent6"/>
+          </a:fillRef>
+          <a:effectRef idx="0">
+            <a:schemeClr val="accent6"/>
+          </a:effectRef>
+          <a:fontRef idx="minor">
+            <a:schemeClr val="lt1"/>
+          </a:fontRef>
+        </p:style>
+        <p:txBody>
+          <a:bodyPr rtlCol="0" anchor="ctr"/>
+          <a:lstStyle/>
+          <a:p>
+            <a:pPr algn="ctr"/>
+            <a:r>
+              <a:rPr lang="en-US" altLang="zh-CN" b="1" dirty="0" err="1"/>
+              <a:t>DeflaterSink</a:t>
+            </a:r>
+            <a:endParaRPr lang="en-US" altLang="zh-CN" b="1" dirty="0"/>
+          </a:p>
+          <a:p>
+            <a:pPr algn="ctr"/>
+            <a:r>
+              <a:rPr lang="en-US" altLang="zh-CN" b="1" dirty="0" err="1"/>
+              <a:t>InflaterSource</a:t>
             </a:r>
             <a:endParaRPr lang="zh-CN" altLang="en-US" b="1" dirty="0"/>
           </a:p>
@@ -4357,8 +4804,8 @@
         </p:nvSpPr>
         <p:spPr>
           <a:xfrm>
-            <a:off x="3210912" y="2400175"/>
-            <a:ext cx="2675734" cy="1200329"/>
+            <a:off x="3342359" y="2400175"/>
+            <a:ext cx="2412841" cy="1200329"/>
           </a:xfrm>
           <a:prstGeom prst="rect">
             <a:avLst/>
@@ -4386,7 +4833,7 @@
                   </a:outerShdw>
                 </a:effectLst>
               </a:rPr>
-              <a:t>L</a:t>
+              <a:t>OK</a:t>
             </a:r>
             <a:r>
               <a:rPr lang="en-US" altLang="zh-CN" sz="7200" b="1" dirty="0">
@@ -4402,39 +4849,7 @@
                   </a:outerShdw>
                 </a:effectLst>
               </a:rPr>
-              <a:t>O</a:t>
-            </a:r>
-            <a:r>
-              <a:rPr lang="en-US" altLang="zh-CN" sz="7200" b="1" dirty="0">
-                <a:ln w="0"/>
-                <a:solidFill>
-                  <a:srgbClr val="7030A0"/>
-                </a:solidFill>
-                <a:effectLst>
-                  <a:outerShdw blurRad="38100" dist="19050" dir="2700000" algn="tl" rotWithShape="0">
-                    <a:schemeClr val="dk1">
-                      <a:alpha val="40000"/>
-                    </a:schemeClr>
-                  </a:outerShdw>
-                </a:effectLst>
-              </a:rPr>
-              <a:t>G</a:t>
-            </a:r>
-            <a:r>
-              <a:rPr lang="en-US" altLang="zh-CN" sz="7200" b="1" dirty="0">
-                <a:ln w="0"/>
-                <a:solidFill>
-                  <a:srgbClr val="00B050"/>
-                </a:solidFill>
-                <a:effectLst>
-                  <a:outerShdw blurRad="38100" dist="19050" dir="2700000" algn="tl" rotWithShape="0">
-                    <a:schemeClr val="dk1">
-                      <a:alpha val="40000"/>
-                    </a:schemeClr>
-                  </a:outerShdw>
-                </a:effectLst>
-              </a:rPr>
-              <a:t>O</a:t>
+              <a:t>IO</a:t>
             </a:r>
             <a:endParaRPr lang="zh-CN" altLang="en-US" sz="7200" b="1" cap="none" spc="0" dirty="0">
               <a:ln w="22225">

</xml_diff>